<commit_message>
up date with integration of predictions
</commit_message>
<xml_diff>
--- a/figures/Figure_3.pptx
+++ b/figures/Figure_3.pptx
@@ -197,7 +197,7 @@
           <a:p>
             <a:fld id="{498D7E84-9E83-884E-975C-BAEF30A447D1}" type="datetimeFigureOut">
               <a:rPr lang="fr-FR" smtClean="0"/>
-              <a:t>16/07/2025</a:t>
+              <a:t>23/07/2025</a:t>
             </a:fld>
             <a:endParaRPr lang="fr-FR"/>
           </a:p>
@@ -684,7 +684,7 @@
           <a:p>
             <a:fld id="{9A568DE9-78C7-6145-A01B-879F4074346E}" type="datetimeFigureOut">
               <a:rPr lang="fr-FR" smtClean="0"/>
-              <a:t>16/07/2025</a:t>
+              <a:t>23/07/2025</a:t>
             </a:fld>
             <a:endParaRPr lang="fr-FR"/>
           </a:p>
@@ -854,7 +854,7 @@
           <a:p>
             <a:fld id="{9A568DE9-78C7-6145-A01B-879F4074346E}" type="datetimeFigureOut">
               <a:rPr lang="fr-FR" smtClean="0"/>
-              <a:t>16/07/2025</a:t>
+              <a:t>23/07/2025</a:t>
             </a:fld>
             <a:endParaRPr lang="fr-FR"/>
           </a:p>
@@ -1034,7 +1034,7 @@
           <a:p>
             <a:fld id="{9A568DE9-78C7-6145-A01B-879F4074346E}" type="datetimeFigureOut">
               <a:rPr lang="fr-FR" smtClean="0"/>
-              <a:t>16/07/2025</a:t>
+              <a:t>23/07/2025</a:t>
             </a:fld>
             <a:endParaRPr lang="fr-FR"/>
           </a:p>
@@ -1204,7 +1204,7 @@
           <a:p>
             <a:fld id="{9A568DE9-78C7-6145-A01B-879F4074346E}" type="datetimeFigureOut">
               <a:rPr lang="fr-FR" smtClean="0"/>
-              <a:t>16/07/2025</a:t>
+              <a:t>23/07/2025</a:t>
             </a:fld>
             <a:endParaRPr lang="fr-FR"/>
           </a:p>
@@ -1450,7 +1450,7 @@
           <a:p>
             <a:fld id="{9A568DE9-78C7-6145-A01B-879F4074346E}" type="datetimeFigureOut">
               <a:rPr lang="fr-FR" smtClean="0"/>
-              <a:t>16/07/2025</a:t>
+              <a:t>23/07/2025</a:t>
             </a:fld>
             <a:endParaRPr lang="fr-FR"/>
           </a:p>
@@ -1682,7 +1682,7 @@
           <a:p>
             <a:fld id="{9A568DE9-78C7-6145-A01B-879F4074346E}" type="datetimeFigureOut">
               <a:rPr lang="fr-FR" smtClean="0"/>
-              <a:t>16/07/2025</a:t>
+              <a:t>23/07/2025</a:t>
             </a:fld>
             <a:endParaRPr lang="fr-FR"/>
           </a:p>
@@ -2049,7 +2049,7 @@
           <a:p>
             <a:fld id="{9A568DE9-78C7-6145-A01B-879F4074346E}" type="datetimeFigureOut">
               <a:rPr lang="fr-FR" smtClean="0"/>
-              <a:t>16/07/2025</a:t>
+              <a:t>23/07/2025</a:t>
             </a:fld>
             <a:endParaRPr lang="fr-FR"/>
           </a:p>
@@ -2167,7 +2167,7 @@
           <a:p>
             <a:fld id="{9A568DE9-78C7-6145-A01B-879F4074346E}" type="datetimeFigureOut">
               <a:rPr lang="fr-FR" smtClean="0"/>
-              <a:t>16/07/2025</a:t>
+              <a:t>23/07/2025</a:t>
             </a:fld>
             <a:endParaRPr lang="fr-FR"/>
           </a:p>
@@ -2262,7 +2262,7 @@
           <a:p>
             <a:fld id="{9A568DE9-78C7-6145-A01B-879F4074346E}" type="datetimeFigureOut">
               <a:rPr lang="fr-FR" smtClean="0"/>
-              <a:t>16/07/2025</a:t>
+              <a:t>23/07/2025</a:t>
             </a:fld>
             <a:endParaRPr lang="fr-FR"/>
           </a:p>
@@ -2539,7 +2539,7 @@
           <a:p>
             <a:fld id="{9A568DE9-78C7-6145-A01B-879F4074346E}" type="datetimeFigureOut">
               <a:rPr lang="fr-FR" smtClean="0"/>
-              <a:t>16/07/2025</a:t>
+              <a:t>23/07/2025</a:t>
             </a:fld>
             <a:endParaRPr lang="fr-FR"/>
           </a:p>
@@ -2796,7 +2796,7 @@
           <a:p>
             <a:fld id="{9A568DE9-78C7-6145-A01B-879F4074346E}" type="datetimeFigureOut">
               <a:rPr lang="fr-FR" smtClean="0"/>
-              <a:t>16/07/2025</a:t>
+              <a:t>23/07/2025</a:t>
             </a:fld>
             <a:endParaRPr lang="fr-FR"/>
           </a:p>
@@ -3009,7 +3009,7 @@
           <a:p>
             <a:fld id="{9A568DE9-78C7-6145-A01B-879F4074346E}" type="datetimeFigureOut">
               <a:rPr lang="fr-FR" smtClean="0"/>
-              <a:t>16/07/2025</a:t>
+              <a:t>23/07/2025</a:t>
             </a:fld>
             <a:endParaRPr lang="fr-FR"/>
           </a:p>
@@ -3416,57 +3416,10 @@
       </p:grpSpPr>
       <p:sp>
         <p:nvSpPr>
-          <p:cNvPr id="79" name="ZoneTexte 78">
+          <p:cNvPr id="9" name="Rectangle : coins arrondis 8">
             <a:extLst>
               <a:ext uri="{FF2B5EF4-FFF2-40B4-BE49-F238E27FC236}">
-                <a16:creationId xmlns:a16="http://schemas.microsoft.com/office/drawing/2014/main" id="{18AE7EF2-DF27-ABBF-9043-493680FCA0E5}"/>
-              </a:ext>
-            </a:extLst>
-          </p:cNvPr>
-          <p:cNvSpPr txBox="1"/>
-          <p:nvPr/>
-        </p:nvSpPr>
-        <p:spPr>
-          <a:xfrm>
-            <a:off x="922413" y="621783"/>
-            <a:ext cx="935256" cy="307777"/>
-          </a:xfrm>
-          <a:prstGeom prst="rect">
-            <a:avLst/>
-          </a:prstGeom>
-          <a:noFill/>
-        </p:spPr>
-        <p:txBody>
-          <a:bodyPr wrap="square" rtlCol="0">
-            <a:spAutoFit/>
-          </a:bodyPr>
-          <a:lstStyle/>
-          <a:p>
-            <a:pPr algn="ctr"/>
-            <a:r>
-              <a:rPr lang="en-GB" sz="700" b="1" dirty="0"/>
-              <a:t>No integration</a:t>
-            </a:r>
-          </a:p>
-          <a:p>
-            <a:pPr algn="ctr"/>
-            <a:r>
-              <a:rPr lang="en-GB" sz="700" b="1" dirty="0">
-                <a:solidFill>
-                  <a:srgbClr val="C00000"/>
-                </a:solidFill>
-              </a:rPr>
-              <a:t>Unimodal models</a:t>
-            </a:r>
-          </a:p>
-        </p:txBody>
-      </p:sp>
-      <p:sp>
-        <p:nvSpPr>
-          <p:cNvPr id="4" name="Rectangle : coins arrondis 3">
-            <a:extLst>
-              <a:ext uri="{FF2B5EF4-FFF2-40B4-BE49-F238E27FC236}">
-                <a16:creationId xmlns:a16="http://schemas.microsoft.com/office/drawing/2014/main" id="{F978B96B-7472-FF63-1B51-02DE72DFE42C}"/>
+                <a16:creationId xmlns:a16="http://schemas.microsoft.com/office/drawing/2014/main" id="{721A1601-013B-EB20-797D-567CC9B993AD}"/>
               </a:ext>
             </a:extLst>
           </p:cNvPr>
@@ -3475,8 +3428,8 @@
         </p:nvSpPr>
         <p:spPr>
           <a:xfrm>
-            <a:off x="2384979" y="923708"/>
-            <a:ext cx="508580" cy="169132"/>
+            <a:off x="941007" y="1734197"/>
+            <a:ext cx="707385" cy="169132"/>
           </a:xfrm>
           <a:prstGeom prst="roundRect">
             <a:avLst/>
@@ -3514,10 +3467,10 @@
       </p:sp>
       <p:sp>
         <p:nvSpPr>
-          <p:cNvPr id="80" name="ZoneTexte 79">
+          <p:cNvPr id="79" name="ZoneTexte 78">
             <a:extLst>
               <a:ext uri="{FF2B5EF4-FFF2-40B4-BE49-F238E27FC236}">
-                <a16:creationId xmlns:a16="http://schemas.microsoft.com/office/drawing/2014/main" id="{C2A6EDE1-26D4-C51C-1081-B5BBBFAB63AD}"/>
+                <a16:creationId xmlns:a16="http://schemas.microsoft.com/office/drawing/2014/main" id="{18AE7EF2-DF27-ABBF-9043-493680FCA0E5}"/>
               </a:ext>
             </a:extLst>
           </p:cNvPr>
@@ -3526,8 +3479,8 @@
         </p:nvSpPr>
         <p:spPr>
           <a:xfrm>
-            <a:off x="1964727" y="616948"/>
-            <a:ext cx="1357512" cy="307777"/>
+            <a:off x="732545" y="620748"/>
+            <a:ext cx="1190653" cy="307777"/>
           </a:xfrm>
           <a:prstGeom prst="rect">
             <a:avLst/>
@@ -3543,15 +3496,7 @@
             <a:pPr algn="ctr"/>
             <a:r>
               <a:rPr lang="en-GB" sz="700" b="1" dirty="0"/>
-              <a:t>Pooled</a:t>
-            </a:r>
-            <a:r>
-              <a:rPr lang="en-GB" sz="700" dirty="0"/>
-              <a:t> </a:t>
-            </a:r>
-            <a:r>
-              <a:rPr lang="en-GB" sz="700" b="1" dirty="0"/>
-              <a:t>data integration</a:t>
+              <a:t>Pooled model integration</a:t>
             </a:r>
           </a:p>
           <a:p>
@@ -3562,17 +3507,17 @@
                   <a:srgbClr val="C00000"/>
                 </a:solidFill>
               </a:rPr>
-              <a:t>Multimodal model</a:t>
-            </a:r>
-          </a:p>
-        </p:txBody>
-      </p:sp>
-      <p:sp>
-        <p:nvSpPr>
-          <p:cNvPr id="103" name="Flèche vers la gauche 102">
+              <a:t>Unimodal models</a:t>
+            </a:r>
+          </a:p>
+        </p:txBody>
+      </p:sp>
+      <p:sp>
+        <p:nvSpPr>
+          <p:cNvPr id="4" name="Rectangle : coins arrondis 3">
             <a:extLst>
               <a:ext uri="{FF2B5EF4-FFF2-40B4-BE49-F238E27FC236}">
-                <a16:creationId xmlns:a16="http://schemas.microsoft.com/office/drawing/2014/main" id="{26D75E03-134C-2748-F1AC-6C06561E3462}"/>
+                <a16:creationId xmlns:a16="http://schemas.microsoft.com/office/drawing/2014/main" id="{F978B96B-7472-FF63-1B51-02DE72DFE42C}"/>
               </a:ext>
             </a:extLst>
           </p:cNvPr>
@@ -3580,104 +3525,16 @@
           <p:nvPr/>
         </p:nvSpPr>
         <p:spPr>
-          <a:xfrm rot="16200000">
-            <a:off x="978952" y="1193080"/>
-            <a:ext cx="144467" cy="99705"/>
-          </a:xfrm>
-          <a:prstGeom prst="leftArrow">
+          <a:xfrm>
+            <a:off x="2508159" y="923708"/>
+            <a:ext cx="508580" cy="169132"/>
+          </a:xfrm>
+          <a:prstGeom prst="roundRect">
             <a:avLst/>
           </a:prstGeom>
           <a:solidFill>
-            <a:schemeClr val="bg2">
+            <a:schemeClr val="bg1">
               <a:lumMod val="75000"/>
-            </a:schemeClr>
-          </a:solidFill>
-          <a:ln>
-            <a:noFill/>
-          </a:ln>
-        </p:spPr>
-        <p:style>
-          <a:lnRef idx="3">
-            <a:schemeClr val="lt1"/>
-          </a:lnRef>
-          <a:fillRef idx="1">
-            <a:schemeClr val="dk1"/>
-          </a:fillRef>
-          <a:effectRef idx="1">
-            <a:schemeClr val="dk1"/>
-          </a:effectRef>
-          <a:fontRef idx="minor">
-            <a:schemeClr val="lt1"/>
-          </a:fontRef>
-        </p:style>
-        <p:txBody>
-          <a:bodyPr rtlCol="0" anchor="ctr"/>
-          <a:lstStyle/>
-          <a:p>
-            <a:pPr algn="ctr"/>
-            <a:endParaRPr lang="fr-FR" sz="900"/>
-          </a:p>
-        </p:txBody>
-      </p:sp>
-      <p:sp>
-        <p:nvSpPr>
-          <p:cNvPr id="113" name="ZoneTexte 112">
-            <a:extLst>
-              <a:ext uri="{FF2B5EF4-FFF2-40B4-BE49-F238E27FC236}">
-                <a16:creationId xmlns:a16="http://schemas.microsoft.com/office/drawing/2014/main" id="{E5DCF8BD-628E-F0F7-54F6-3C3E391316B9}"/>
-              </a:ext>
-            </a:extLst>
-          </p:cNvPr>
-          <p:cNvSpPr txBox="1"/>
-          <p:nvPr/>
-        </p:nvSpPr>
-        <p:spPr>
-          <a:xfrm>
-            <a:off x="896586" y="1331567"/>
-            <a:ext cx="343364" cy="230832"/>
-          </a:xfrm>
-          <a:prstGeom prst="rect">
-            <a:avLst/>
-          </a:prstGeom>
-          <a:noFill/>
-        </p:spPr>
-        <p:txBody>
-          <a:bodyPr wrap="none" rtlCol="0">
-            <a:spAutoFit/>
-          </a:bodyPr>
-          <a:lstStyle/>
-          <a:p>
-            <a:r>
-              <a:rPr lang="fr-FR" sz="900" b="1" dirty="0"/>
-              <a:t>M1</a:t>
-            </a:r>
-          </a:p>
-        </p:txBody>
-      </p:sp>
-      <p:sp>
-        <p:nvSpPr>
-          <p:cNvPr id="2" name="Rectangle : coins arrondis 1">
-            <a:extLst>
-              <a:ext uri="{FF2B5EF4-FFF2-40B4-BE49-F238E27FC236}">
-                <a16:creationId xmlns:a16="http://schemas.microsoft.com/office/drawing/2014/main" id="{775BE4EA-6224-A865-F644-1FCAAA8F0DE7}"/>
-              </a:ext>
-            </a:extLst>
-          </p:cNvPr>
-          <p:cNvSpPr/>
-          <p:nvPr/>
-        </p:nvSpPr>
-        <p:spPr>
-          <a:xfrm>
-            <a:off x="976228" y="925260"/>
-            <a:ext cx="152458" cy="136543"/>
-          </a:xfrm>
-          <a:prstGeom prst="roundRect">
-            <a:avLst/>
-          </a:prstGeom>
-          <a:solidFill>
-            <a:schemeClr val="accent6">
-              <a:lumMod val="20000"/>
-              <a:lumOff val="80000"/>
             </a:schemeClr>
           </a:solidFill>
         </p:spPr>
@@ -3708,10 +3565,65 @@
       </p:sp>
       <p:sp>
         <p:nvSpPr>
-          <p:cNvPr id="6" name="Rectangle : coins arrondis 5">
+          <p:cNvPr id="80" name="ZoneTexte 79">
             <a:extLst>
               <a:ext uri="{FF2B5EF4-FFF2-40B4-BE49-F238E27FC236}">
-                <a16:creationId xmlns:a16="http://schemas.microsoft.com/office/drawing/2014/main" id="{6F984FF6-9D9D-B60D-1802-2802C3F35CAC}"/>
+                <a16:creationId xmlns:a16="http://schemas.microsoft.com/office/drawing/2014/main" id="{C2A6EDE1-26D4-C51C-1081-B5BBBFAB63AD}"/>
+              </a:ext>
+            </a:extLst>
+          </p:cNvPr>
+          <p:cNvSpPr txBox="1"/>
+          <p:nvPr/>
+        </p:nvSpPr>
+        <p:spPr>
+          <a:xfrm>
+            <a:off x="2087907" y="616948"/>
+            <a:ext cx="1357512" cy="307777"/>
+          </a:xfrm>
+          <a:prstGeom prst="rect">
+            <a:avLst/>
+          </a:prstGeom>
+          <a:noFill/>
+        </p:spPr>
+        <p:txBody>
+          <a:bodyPr wrap="square" rtlCol="0">
+            <a:spAutoFit/>
+          </a:bodyPr>
+          <a:lstStyle/>
+          <a:p>
+            <a:pPr algn="ctr"/>
+            <a:r>
+              <a:rPr lang="en-GB" sz="700" b="1" dirty="0"/>
+              <a:t>Pooled</a:t>
+            </a:r>
+            <a:r>
+              <a:rPr lang="en-GB" sz="700" dirty="0"/>
+              <a:t> </a:t>
+            </a:r>
+            <a:r>
+              <a:rPr lang="en-GB" sz="700" b="1" dirty="0"/>
+              <a:t>data integration</a:t>
+            </a:r>
+          </a:p>
+          <a:p>
+            <a:pPr algn="ctr"/>
+            <a:r>
+              <a:rPr lang="en-GB" sz="700" b="1" dirty="0">
+                <a:solidFill>
+                  <a:srgbClr val="C00000"/>
+                </a:solidFill>
+              </a:rPr>
+              <a:t>Multimodal model</a:t>
+            </a:r>
+          </a:p>
+        </p:txBody>
+      </p:sp>
+      <p:sp>
+        <p:nvSpPr>
+          <p:cNvPr id="103" name="Flèche vers la gauche 102">
+            <a:extLst>
+              <a:ext uri="{FF2B5EF4-FFF2-40B4-BE49-F238E27FC236}">
+                <a16:creationId xmlns:a16="http://schemas.microsoft.com/office/drawing/2014/main" id="{26D75E03-134C-2748-F1AC-6C06561E3462}"/>
               </a:ext>
             </a:extLst>
           </p:cNvPr>
@@ -3719,15 +3631,102 @@
           <p:nvPr/>
         </p:nvSpPr>
         <p:spPr>
-          <a:xfrm>
-            <a:off x="1305196" y="929949"/>
+          <a:xfrm rot="16200000">
+            <a:off x="978952" y="1193080"/>
+            <a:ext cx="144467" cy="99705"/>
+          </a:xfrm>
+          <a:prstGeom prst="leftArrow">
+            <a:avLst/>
+          </a:prstGeom>
+          <a:solidFill>
+            <a:schemeClr val="bg2">
+              <a:lumMod val="75000"/>
+            </a:schemeClr>
+          </a:solidFill>
+          <a:ln>
+            <a:noFill/>
+          </a:ln>
+        </p:spPr>
+        <p:style>
+          <a:lnRef idx="3">
+            <a:schemeClr val="lt1"/>
+          </a:lnRef>
+          <a:fillRef idx="1">
+            <a:schemeClr val="dk1"/>
+          </a:fillRef>
+          <a:effectRef idx="1">
+            <a:schemeClr val="dk1"/>
+          </a:effectRef>
+          <a:fontRef idx="minor">
+            <a:schemeClr val="lt1"/>
+          </a:fontRef>
+        </p:style>
+        <p:txBody>
+          <a:bodyPr rtlCol="0" anchor="ctr"/>
+          <a:lstStyle/>
+          <a:p>
+            <a:pPr algn="ctr"/>
+            <a:endParaRPr lang="fr-FR" sz="900"/>
+          </a:p>
+        </p:txBody>
+      </p:sp>
+      <p:sp>
+        <p:nvSpPr>
+          <p:cNvPr id="113" name="ZoneTexte 112">
+            <a:extLst>
+              <a:ext uri="{FF2B5EF4-FFF2-40B4-BE49-F238E27FC236}">
+                <a16:creationId xmlns:a16="http://schemas.microsoft.com/office/drawing/2014/main" id="{E5DCF8BD-628E-F0F7-54F6-3C3E391316B9}"/>
+              </a:ext>
+            </a:extLst>
+          </p:cNvPr>
+          <p:cNvSpPr txBox="1"/>
+          <p:nvPr/>
+        </p:nvSpPr>
+        <p:spPr>
+          <a:xfrm>
+            <a:off x="896586" y="1331567"/>
+            <a:ext cx="343364" cy="230832"/>
+          </a:xfrm>
+          <a:prstGeom prst="rect">
+            <a:avLst/>
+          </a:prstGeom>
+          <a:noFill/>
+        </p:spPr>
+        <p:txBody>
+          <a:bodyPr wrap="none" rtlCol="0">
+            <a:spAutoFit/>
+          </a:bodyPr>
+          <a:lstStyle/>
+          <a:p>
+            <a:r>
+              <a:rPr lang="fr-FR" sz="900" b="1" dirty="0"/>
+              <a:t>M1</a:t>
+            </a:r>
+          </a:p>
+        </p:txBody>
+      </p:sp>
+      <p:sp>
+        <p:nvSpPr>
+          <p:cNvPr id="2" name="Rectangle : coins arrondis 1">
+            <a:extLst>
+              <a:ext uri="{FF2B5EF4-FFF2-40B4-BE49-F238E27FC236}">
+                <a16:creationId xmlns:a16="http://schemas.microsoft.com/office/drawing/2014/main" id="{775BE4EA-6224-A865-F644-1FCAAA8F0DE7}"/>
+              </a:ext>
+            </a:extLst>
+          </p:cNvPr>
+          <p:cNvSpPr/>
+          <p:nvPr/>
+        </p:nvSpPr>
+        <p:spPr>
+          <a:xfrm>
+            <a:off x="976228" y="925260"/>
             <a:ext cx="152458" cy="136543"/>
           </a:xfrm>
           <a:prstGeom prst="roundRect">
             <a:avLst/>
           </a:prstGeom>
           <a:solidFill>
-            <a:schemeClr val="accent5">
+            <a:schemeClr val="accent6">
               <a:lumMod val="20000"/>
               <a:lumOff val="80000"/>
             </a:schemeClr>
@@ -3760,10 +3759,10 @@
       </p:sp>
       <p:sp>
         <p:nvSpPr>
-          <p:cNvPr id="10" name="Rectangle : coins arrondis 9">
+          <p:cNvPr id="6" name="Rectangle : coins arrondis 5">
             <a:extLst>
               <a:ext uri="{FF2B5EF4-FFF2-40B4-BE49-F238E27FC236}">
-                <a16:creationId xmlns:a16="http://schemas.microsoft.com/office/drawing/2014/main" id="{758444EC-2DBE-6B92-7D97-0607595601C2}"/>
+                <a16:creationId xmlns:a16="http://schemas.microsoft.com/office/drawing/2014/main" id="{6F984FF6-9D9D-B60D-1802-2802C3F35CAC}"/>
               </a:ext>
             </a:extLst>
           </p:cNvPr>
@@ -3772,14 +3771,14 @@
         </p:nvSpPr>
         <p:spPr>
           <a:xfrm>
-            <a:off x="1620060" y="931203"/>
+            <a:off x="1224650" y="929949"/>
             <a:ext cx="152458" cy="136543"/>
           </a:xfrm>
           <a:prstGeom prst="roundRect">
             <a:avLst/>
           </a:prstGeom>
           <a:solidFill>
-            <a:schemeClr val="accent2">
+            <a:schemeClr val="accent5">
               <a:lumMod val="20000"/>
               <a:lumOff val="80000"/>
             </a:schemeClr>
@@ -3812,80 +3811,10 @@
       </p:sp>
       <p:sp>
         <p:nvSpPr>
-          <p:cNvPr id="23" name="ZoneTexte 22">
+          <p:cNvPr id="10" name="Rectangle : coins arrondis 9">
             <a:extLst>
               <a:ext uri="{FF2B5EF4-FFF2-40B4-BE49-F238E27FC236}">
-                <a16:creationId xmlns:a16="http://schemas.microsoft.com/office/drawing/2014/main" id="{5BBFF380-9244-6D6D-7236-0FF390BD5732}"/>
-              </a:ext>
-            </a:extLst>
-          </p:cNvPr>
-          <p:cNvSpPr txBox="1"/>
-          <p:nvPr/>
-        </p:nvSpPr>
-        <p:spPr>
-          <a:xfrm>
-            <a:off x="1214747" y="1331567"/>
-            <a:ext cx="343364" cy="230832"/>
-          </a:xfrm>
-          <a:prstGeom prst="rect">
-            <a:avLst/>
-          </a:prstGeom>
-          <a:noFill/>
-        </p:spPr>
-        <p:txBody>
-          <a:bodyPr wrap="none" rtlCol="0">
-            <a:spAutoFit/>
-          </a:bodyPr>
-          <a:lstStyle/>
-          <a:p>
-            <a:r>
-              <a:rPr lang="fr-FR" sz="900" b="1" dirty="0"/>
-              <a:t>M2</a:t>
-            </a:r>
-          </a:p>
-        </p:txBody>
-      </p:sp>
-      <p:sp>
-        <p:nvSpPr>
-          <p:cNvPr id="24" name="ZoneTexte 23">
-            <a:extLst>
-              <a:ext uri="{FF2B5EF4-FFF2-40B4-BE49-F238E27FC236}">
-                <a16:creationId xmlns:a16="http://schemas.microsoft.com/office/drawing/2014/main" id="{042D7C86-A089-8A45-212A-EABB9F038A3A}"/>
-              </a:ext>
-            </a:extLst>
-          </p:cNvPr>
-          <p:cNvSpPr txBox="1"/>
-          <p:nvPr/>
-        </p:nvSpPr>
-        <p:spPr>
-          <a:xfrm>
-            <a:off x="1537761" y="1331567"/>
-            <a:ext cx="343364" cy="230832"/>
-          </a:xfrm>
-          <a:prstGeom prst="rect">
-            <a:avLst/>
-          </a:prstGeom>
-          <a:noFill/>
-        </p:spPr>
-        <p:txBody>
-          <a:bodyPr wrap="none" rtlCol="0">
-            <a:spAutoFit/>
-          </a:bodyPr>
-          <a:lstStyle/>
-          <a:p>
-            <a:r>
-              <a:rPr lang="fr-FR" sz="900" b="1" dirty="0"/>
-              <a:t>M3</a:t>
-            </a:r>
-          </a:p>
-        </p:txBody>
-      </p:sp>
-      <p:sp>
-        <p:nvSpPr>
-          <p:cNvPr id="28" name="Rectangle : coins arrondis 27">
-            <a:extLst>
-              <a:ext uri="{FF2B5EF4-FFF2-40B4-BE49-F238E27FC236}">
-                <a16:creationId xmlns:a16="http://schemas.microsoft.com/office/drawing/2014/main" id="{284B0927-1D39-B2E7-63CF-EA79F2FBA886}"/>
+                <a16:creationId xmlns:a16="http://schemas.microsoft.com/office/drawing/2014/main" id="{758444EC-2DBE-6B92-7D97-0607595601C2}"/>
               </a:ext>
             </a:extLst>
           </p:cNvPr>
@@ -3894,15 +3823,16 @@
         </p:nvSpPr>
         <p:spPr>
           <a:xfrm>
-            <a:off x="974955" y="1750493"/>
+            <a:off x="1458972" y="931203"/>
             <a:ext cx="152458" cy="136543"/>
           </a:xfrm>
           <a:prstGeom prst="roundRect">
             <a:avLst/>
           </a:prstGeom>
           <a:solidFill>
-            <a:schemeClr val="bg2">
-              <a:lumMod val="50000"/>
+            <a:schemeClr val="accent2">
+              <a:lumMod val="20000"/>
+              <a:lumOff val="80000"/>
             </a:schemeClr>
           </a:solidFill>
         </p:spPr>
@@ -3933,10 +3863,80 @@
       </p:sp>
       <p:sp>
         <p:nvSpPr>
-          <p:cNvPr id="29" name="Rectangle : coins arrondis 28">
+          <p:cNvPr id="23" name="ZoneTexte 22">
             <a:extLst>
               <a:ext uri="{FF2B5EF4-FFF2-40B4-BE49-F238E27FC236}">
-                <a16:creationId xmlns:a16="http://schemas.microsoft.com/office/drawing/2014/main" id="{8EABACFB-BEEE-F368-8C24-09E2B94B4277}"/>
+                <a16:creationId xmlns:a16="http://schemas.microsoft.com/office/drawing/2014/main" id="{5BBFF380-9244-6D6D-7236-0FF390BD5732}"/>
+              </a:ext>
+            </a:extLst>
+          </p:cNvPr>
+          <p:cNvSpPr txBox="1"/>
+          <p:nvPr/>
+        </p:nvSpPr>
+        <p:spPr>
+          <a:xfrm>
+            <a:off x="1129589" y="1328071"/>
+            <a:ext cx="343364" cy="230832"/>
+          </a:xfrm>
+          <a:prstGeom prst="rect">
+            <a:avLst/>
+          </a:prstGeom>
+          <a:noFill/>
+        </p:spPr>
+        <p:txBody>
+          <a:bodyPr wrap="none" rtlCol="0">
+            <a:spAutoFit/>
+          </a:bodyPr>
+          <a:lstStyle/>
+          <a:p>
+            <a:r>
+              <a:rPr lang="fr-FR" sz="900" b="1" dirty="0"/>
+              <a:t>M2</a:t>
+            </a:r>
+          </a:p>
+        </p:txBody>
+      </p:sp>
+      <p:sp>
+        <p:nvSpPr>
+          <p:cNvPr id="24" name="ZoneTexte 23">
+            <a:extLst>
+              <a:ext uri="{FF2B5EF4-FFF2-40B4-BE49-F238E27FC236}">
+                <a16:creationId xmlns:a16="http://schemas.microsoft.com/office/drawing/2014/main" id="{042D7C86-A089-8A45-212A-EABB9F038A3A}"/>
+              </a:ext>
+            </a:extLst>
+          </p:cNvPr>
+          <p:cNvSpPr txBox="1"/>
+          <p:nvPr/>
+        </p:nvSpPr>
+        <p:spPr>
+          <a:xfrm>
+            <a:off x="1376673" y="1331567"/>
+            <a:ext cx="343364" cy="230832"/>
+          </a:xfrm>
+          <a:prstGeom prst="rect">
+            <a:avLst/>
+          </a:prstGeom>
+          <a:noFill/>
+        </p:spPr>
+        <p:txBody>
+          <a:bodyPr wrap="none" rtlCol="0">
+            <a:spAutoFit/>
+          </a:bodyPr>
+          <a:lstStyle/>
+          <a:p>
+            <a:r>
+              <a:rPr lang="fr-FR" sz="900" b="1" dirty="0"/>
+              <a:t>M3</a:t>
+            </a:r>
+          </a:p>
+        </p:txBody>
+      </p:sp>
+      <p:sp>
+        <p:nvSpPr>
+          <p:cNvPr id="28" name="Rectangle : coins arrondis 27">
+            <a:extLst>
+              <a:ext uri="{FF2B5EF4-FFF2-40B4-BE49-F238E27FC236}">
+                <a16:creationId xmlns:a16="http://schemas.microsoft.com/office/drawing/2014/main" id="{284B0927-1D39-B2E7-63CF-EA79F2FBA886}"/>
               </a:ext>
             </a:extLst>
           </p:cNvPr>
@@ -3945,7 +3945,7 @@
         </p:nvSpPr>
         <p:spPr>
           <a:xfrm>
-            <a:off x="1304487" y="1750493"/>
+            <a:off x="974955" y="1750493"/>
             <a:ext cx="152458" cy="136543"/>
           </a:xfrm>
           <a:prstGeom prst="roundRect">
@@ -3984,10 +3984,10 @@
       </p:sp>
       <p:sp>
         <p:nvSpPr>
-          <p:cNvPr id="30" name="Rectangle : coins arrondis 29">
+          <p:cNvPr id="29" name="Rectangle : coins arrondis 28">
             <a:extLst>
               <a:ext uri="{FF2B5EF4-FFF2-40B4-BE49-F238E27FC236}">
-                <a16:creationId xmlns:a16="http://schemas.microsoft.com/office/drawing/2014/main" id="{9C0A4D17-C97E-A113-52B6-F480FD2830B2}"/>
+                <a16:creationId xmlns:a16="http://schemas.microsoft.com/office/drawing/2014/main" id="{8EABACFB-BEEE-F368-8C24-09E2B94B4277}"/>
               </a:ext>
             </a:extLst>
           </p:cNvPr>
@@ -3996,7 +3996,7 @@
         </p:nvSpPr>
         <p:spPr>
           <a:xfrm>
-            <a:off x="1620060" y="1755459"/>
+            <a:off x="1223941" y="1750493"/>
             <a:ext cx="152458" cy="136543"/>
           </a:xfrm>
           <a:prstGeom prst="roundRect">
@@ -4035,10 +4035,10 @@
       </p:sp>
       <p:sp>
         <p:nvSpPr>
-          <p:cNvPr id="76" name="Rectangle : coins arrondis 75">
+          <p:cNvPr id="30" name="Rectangle : coins arrondis 29">
             <a:extLst>
               <a:ext uri="{FF2B5EF4-FFF2-40B4-BE49-F238E27FC236}">
-                <a16:creationId xmlns:a16="http://schemas.microsoft.com/office/drawing/2014/main" id="{5C2EE547-8918-F81C-C722-8C870F5345CE}"/>
+                <a16:creationId xmlns:a16="http://schemas.microsoft.com/office/drawing/2014/main" id="{9C0A4D17-C97E-A113-52B6-F480FD2830B2}"/>
               </a:ext>
             </a:extLst>
           </p:cNvPr>
@@ -4047,16 +4047,15 @@
         </p:nvSpPr>
         <p:spPr>
           <a:xfrm>
-            <a:off x="2403676" y="939236"/>
+            <a:off x="1458972" y="1750492"/>
             <a:ext cx="152458" cy="136543"/>
           </a:xfrm>
           <a:prstGeom prst="roundRect">
             <a:avLst/>
           </a:prstGeom>
           <a:solidFill>
-            <a:schemeClr val="accent6">
-              <a:lumMod val="20000"/>
-              <a:lumOff val="80000"/>
+            <a:schemeClr val="bg2">
+              <a:lumMod val="50000"/>
             </a:schemeClr>
           </a:solidFill>
         </p:spPr>
@@ -4087,10 +4086,10 @@
       </p:sp>
       <p:sp>
         <p:nvSpPr>
-          <p:cNvPr id="77" name="Rectangle : coins arrondis 76">
+          <p:cNvPr id="76" name="Rectangle : coins arrondis 75">
             <a:extLst>
               <a:ext uri="{FF2B5EF4-FFF2-40B4-BE49-F238E27FC236}">
-                <a16:creationId xmlns:a16="http://schemas.microsoft.com/office/drawing/2014/main" id="{93BD61E4-0B97-3613-4C76-25C01FDFE9E7}"/>
+                <a16:creationId xmlns:a16="http://schemas.microsoft.com/office/drawing/2014/main" id="{5C2EE547-8918-F81C-C722-8C870F5345CE}"/>
               </a:ext>
             </a:extLst>
           </p:cNvPr>
@@ -4099,14 +4098,14 @@
         </p:nvSpPr>
         <p:spPr>
           <a:xfrm>
-            <a:off x="2563041" y="939236"/>
+            <a:off x="2526856" y="939236"/>
             <a:ext cx="152458" cy="136543"/>
           </a:xfrm>
           <a:prstGeom prst="roundRect">
             <a:avLst/>
           </a:prstGeom>
           <a:solidFill>
-            <a:schemeClr val="accent5">
+            <a:schemeClr val="accent6">
               <a:lumMod val="20000"/>
               <a:lumOff val="80000"/>
             </a:schemeClr>
@@ -4139,10 +4138,10 @@
       </p:sp>
       <p:sp>
         <p:nvSpPr>
-          <p:cNvPr id="87" name="Rectangle : coins arrondis 86">
+          <p:cNvPr id="77" name="Rectangle : coins arrondis 76">
             <a:extLst>
               <a:ext uri="{FF2B5EF4-FFF2-40B4-BE49-F238E27FC236}">
-                <a16:creationId xmlns:a16="http://schemas.microsoft.com/office/drawing/2014/main" id="{5C7DBF4A-0595-00C8-45C9-701591F66FDB}"/>
+                <a16:creationId xmlns:a16="http://schemas.microsoft.com/office/drawing/2014/main" id="{93BD61E4-0B97-3613-4C76-25C01FDFE9E7}"/>
               </a:ext>
             </a:extLst>
           </p:cNvPr>
@@ -4151,14 +4150,14 @@
         </p:nvSpPr>
         <p:spPr>
           <a:xfrm>
-            <a:off x="2719867" y="939236"/>
+            <a:off x="2686221" y="939236"/>
             <a:ext cx="152458" cy="136543"/>
           </a:xfrm>
           <a:prstGeom prst="roundRect">
             <a:avLst/>
           </a:prstGeom>
           <a:solidFill>
-            <a:schemeClr val="accent2">
+            <a:schemeClr val="accent5">
               <a:lumMod val="20000"/>
               <a:lumOff val="80000"/>
             </a:schemeClr>
@@ -4191,45 +4190,10 @@
       </p:sp>
       <p:sp>
         <p:nvSpPr>
-          <p:cNvPr id="110" name="ZoneTexte 109">
+          <p:cNvPr id="87" name="Rectangle : coins arrondis 86">
             <a:extLst>
               <a:ext uri="{FF2B5EF4-FFF2-40B4-BE49-F238E27FC236}">
-                <a16:creationId xmlns:a16="http://schemas.microsoft.com/office/drawing/2014/main" id="{17EFB093-CAA9-8780-EC51-F1455276EA9B}"/>
-              </a:ext>
-            </a:extLst>
-          </p:cNvPr>
-          <p:cNvSpPr txBox="1"/>
-          <p:nvPr/>
-        </p:nvSpPr>
-        <p:spPr>
-          <a:xfrm>
-            <a:off x="2475893" y="1326977"/>
-            <a:ext cx="343364" cy="230832"/>
-          </a:xfrm>
-          <a:prstGeom prst="rect">
-            <a:avLst/>
-          </a:prstGeom>
-          <a:noFill/>
-        </p:spPr>
-        <p:txBody>
-          <a:bodyPr wrap="none" rtlCol="0">
-            <a:spAutoFit/>
-          </a:bodyPr>
-          <a:lstStyle/>
-          <a:p>
-            <a:r>
-              <a:rPr lang="fr-FR" sz="900" b="1" dirty="0"/>
-              <a:t>M4</a:t>
-            </a:r>
-          </a:p>
-        </p:txBody>
-      </p:sp>
-      <p:sp>
-        <p:nvSpPr>
-          <p:cNvPr id="125" name="Rectangle : coins arrondis 124">
-            <a:extLst>
-              <a:ext uri="{FF2B5EF4-FFF2-40B4-BE49-F238E27FC236}">
-                <a16:creationId xmlns:a16="http://schemas.microsoft.com/office/drawing/2014/main" id="{D5C359F6-F32D-ABEC-8AB5-5F852297E03B}"/>
+                <a16:creationId xmlns:a16="http://schemas.microsoft.com/office/drawing/2014/main" id="{5C7DBF4A-0595-00C8-45C9-701591F66FDB}"/>
               </a:ext>
             </a:extLst>
           </p:cNvPr>
@@ -4238,15 +4202,16 @@
         </p:nvSpPr>
         <p:spPr>
           <a:xfrm>
-            <a:off x="2554756" y="1750493"/>
+            <a:off x="2843047" y="939236"/>
             <a:ext cx="152458" cy="136543"/>
           </a:xfrm>
           <a:prstGeom prst="roundRect">
             <a:avLst/>
           </a:prstGeom>
           <a:solidFill>
-            <a:schemeClr val="bg2">
-              <a:lumMod val="50000"/>
+            <a:schemeClr val="accent2">
+              <a:lumMod val="20000"/>
+              <a:lumOff val="80000"/>
             </a:schemeClr>
           </a:solidFill>
         </p:spPr>
@@ -4277,10 +4242,10 @@
       </p:sp>
       <p:sp>
         <p:nvSpPr>
-          <p:cNvPr id="128" name="ZoneTexte 127">
+          <p:cNvPr id="110" name="ZoneTexte 109">
             <a:extLst>
               <a:ext uri="{FF2B5EF4-FFF2-40B4-BE49-F238E27FC236}">
-                <a16:creationId xmlns:a16="http://schemas.microsoft.com/office/drawing/2014/main" id="{3F51A3BF-95D0-2812-03EE-8052FB68D2DF}"/>
+                <a16:creationId xmlns:a16="http://schemas.microsoft.com/office/drawing/2014/main" id="{17EFB093-CAA9-8780-EC51-F1455276EA9B}"/>
               </a:ext>
             </a:extLst>
           </p:cNvPr>
@@ -4289,8 +4254,8 @@
         </p:nvSpPr>
         <p:spPr>
           <a:xfrm>
-            <a:off x="3368764" y="609660"/>
-            <a:ext cx="1486105" cy="307777"/>
+            <a:off x="2599073" y="1326977"/>
+            <a:ext cx="343364" cy="230832"/>
           </a:xfrm>
           <a:prstGeom prst="rect">
             <a:avLst/>
@@ -4298,36 +4263,24 @@
           <a:noFill/>
         </p:spPr>
         <p:txBody>
-          <a:bodyPr wrap="square" rtlCol="0">
+          <a:bodyPr wrap="none" rtlCol="0">
             <a:spAutoFit/>
           </a:bodyPr>
           <a:lstStyle/>
           <a:p>
-            <a:pPr algn="ctr"/>
-            <a:r>
-              <a:rPr lang="en-GB" sz="700" b="1" dirty="0"/>
-              <a:t>Multistep data integration</a:t>
-            </a:r>
-          </a:p>
-          <a:p>
-            <a:pPr algn="ctr"/>
-            <a:r>
-              <a:rPr lang="en-GB" sz="700" b="1" dirty="0">
-                <a:solidFill>
-                  <a:srgbClr val="C00000"/>
-                </a:solidFill>
-              </a:rPr>
-              <a:t>Incremental multimodal model</a:t>
-            </a:r>
-          </a:p>
-        </p:txBody>
-      </p:sp>
-      <p:sp>
-        <p:nvSpPr>
-          <p:cNvPr id="129" name="Rectangle : coins arrondis 128">
+            <a:r>
+              <a:rPr lang="fr-FR" sz="900" b="1" dirty="0"/>
+              <a:t>M5</a:t>
+            </a:r>
+          </a:p>
+        </p:txBody>
+      </p:sp>
+      <p:sp>
+        <p:nvSpPr>
+          <p:cNvPr id="125" name="Rectangle : coins arrondis 124">
             <a:extLst>
               <a:ext uri="{FF2B5EF4-FFF2-40B4-BE49-F238E27FC236}">
-                <a16:creationId xmlns:a16="http://schemas.microsoft.com/office/drawing/2014/main" id="{12DED574-FE3C-AEA3-0655-3CC76E0C13D6}"/>
+                <a16:creationId xmlns:a16="http://schemas.microsoft.com/office/drawing/2014/main" id="{D5C359F6-F32D-ABEC-8AB5-5F852297E03B}"/>
               </a:ext>
             </a:extLst>
           </p:cNvPr>
@@ -4336,16 +4289,15 @@
         </p:nvSpPr>
         <p:spPr>
           <a:xfrm>
-            <a:off x="3316520" y="939471"/>
+            <a:off x="2677936" y="1750493"/>
             <a:ext cx="152458" cy="136543"/>
           </a:xfrm>
           <a:prstGeom prst="roundRect">
             <a:avLst/>
           </a:prstGeom>
           <a:solidFill>
-            <a:schemeClr val="accent6">
-              <a:lumMod val="20000"/>
-              <a:lumOff val="80000"/>
+            <a:schemeClr val="bg2">
+              <a:lumMod val="50000"/>
             </a:schemeClr>
           </a:solidFill>
         </p:spPr>
@@ -4376,10 +4328,10 @@
       </p:sp>
       <p:sp>
         <p:nvSpPr>
-          <p:cNvPr id="131" name="ZoneTexte 130">
+          <p:cNvPr id="128" name="ZoneTexte 127">
             <a:extLst>
               <a:ext uri="{FF2B5EF4-FFF2-40B4-BE49-F238E27FC236}">
-                <a16:creationId xmlns:a16="http://schemas.microsoft.com/office/drawing/2014/main" id="{7EBAD5D0-3621-743A-6AD4-1B78C1BC26E6}"/>
+                <a16:creationId xmlns:a16="http://schemas.microsoft.com/office/drawing/2014/main" id="{3F51A3BF-95D0-2812-03EE-8052FB68D2DF}"/>
               </a:ext>
             </a:extLst>
           </p:cNvPr>
@@ -4388,8 +4340,8 @@
         </p:nvSpPr>
         <p:spPr>
           <a:xfrm>
-            <a:off x="3245945" y="1321164"/>
-            <a:ext cx="343364" cy="230832"/>
+            <a:off x="3491951" y="609660"/>
+            <a:ext cx="1486105" cy="307777"/>
           </a:xfrm>
           <a:prstGeom prst="rect">
             <a:avLst/>
@@ -4397,24 +4349,36 @@
           <a:noFill/>
         </p:spPr>
         <p:txBody>
-          <a:bodyPr wrap="none" rtlCol="0">
+          <a:bodyPr wrap="square" rtlCol="0">
             <a:spAutoFit/>
           </a:bodyPr>
           <a:lstStyle/>
           <a:p>
-            <a:r>
-              <a:rPr lang="fr-FR" sz="900" b="1" dirty="0"/>
-              <a:t>M1</a:t>
-            </a:r>
-          </a:p>
-        </p:txBody>
-      </p:sp>
-      <p:sp>
-        <p:nvSpPr>
-          <p:cNvPr id="133" name="Rectangle : coins arrondis 132">
+            <a:pPr algn="ctr"/>
+            <a:r>
+              <a:rPr lang="en-GB" sz="700" b="1" dirty="0"/>
+              <a:t>Multistep data integration</a:t>
+            </a:r>
+          </a:p>
+          <a:p>
+            <a:pPr algn="ctr"/>
+            <a:r>
+              <a:rPr lang="en-GB" sz="700" b="1" dirty="0">
+                <a:solidFill>
+                  <a:srgbClr val="C00000"/>
+                </a:solidFill>
+              </a:rPr>
+              <a:t>Incremental multimodal model</a:t>
+            </a:r>
+          </a:p>
+        </p:txBody>
+      </p:sp>
+      <p:sp>
+        <p:nvSpPr>
+          <p:cNvPr id="129" name="Rectangle : coins arrondis 128">
             <a:extLst>
               <a:ext uri="{FF2B5EF4-FFF2-40B4-BE49-F238E27FC236}">
-                <a16:creationId xmlns:a16="http://schemas.microsoft.com/office/drawing/2014/main" id="{7E941BCC-04C3-1456-F746-EB363313BA03}"/>
+                <a16:creationId xmlns:a16="http://schemas.microsoft.com/office/drawing/2014/main" id="{12DED574-FE3C-AEA3-0655-3CC76E0C13D6}"/>
               </a:ext>
             </a:extLst>
           </p:cNvPr>
@@ -4423,14 +4387,14 @@
         </p:nvSpPr>
         <p:spPr>
           <a:xfrm>
-            <a:off x="3724102" y="1362312"/>
+            <a:off x="3439707" y="939471"/>
             <a:ext cx="152458" cy="136543"/>
           </a:xfrm>
           <a:prstGeom prst="roundRect">
             <a:avLst/>
           </a:prstGeom>
           <a:solidFill>
-            <a:schemeClr val="accent5">
+            <a:schemeClr val="accent6">
               <a:lumMod val="20000"/>
               <a:lumOff val="80000"/>
             </a:schemeClr>
@@ -4463,10 +4427,10 @@
       </p:sp>
       <p:sp>
         <p:nvSpPr>
-          <p:cNvPr id="135" name="ZoneTexte 134">
+          <p:cNvPr id="131" name="ZoneTexte 130">
             <a:extLst>
               <a:ext uri="{FF2B5EF4-FFF2-40B4-BE49-F238E27FC236}">
-                <a16:creationId xmlns:a16="http://schemas.microsoft.com/office/drawing/2014/main" id="{F8D97D9F-345F-FD52-E860-E64F2756361F}"/>
+                <a16:creationId xmlns:a16="http://schemas.microsoft.com/office/drawing/2014/main" id="{7EBAD5D0-3621-743A-6AD4-1B78C1BC26E6}"/>
               </a:ext>
             </a:extLst>
           </p:cNvPr>
@@ -4475,8 +4439,8 @@
         </p:nvSpPr>
         <p:spPr>
           <a:xfrm>
-            <a:off x="4027892" y="1315164"/>
-            <a:ext cx="401072" cy="230832"/>
+            <a:off x="3369132" y="1321164"/>
+            <a:ext cx="343364" cy="230832"/>
           </a:xfrm>
           <a:prstGeom prst="rect">
             <a:avLst/>
@@ -4491,17 +4455,17 @@
           <a:p>
             <a:r>
               <a:rPr lang="fr-FR" sz="900" b="1" dirty="0"/>
-              <a:t>*M5</a:t>
-            </a:r>
-          </a:p>
-        </p:txBody>
-      </p:sp>
-      <p:sp>
-        <p:nvSpPr>
-          <p:cNvPr id="137" name="Rectangle : coins arrondis 136">
+              <a:t>M1</a:t>
+            </a:r>
+          </a:p>
+        </p:txBody>
+      </p:sp>
+      <p:sp>
+        <p:nvSpPr>
+          <p:cNvPr id="133" name="Rectangle : coins arrondis 132">
             <a:extLst>
               <a:ext uri="{FF2B5EF4-FFF2-40B4-BE49-F238E27FC236}">
-                <a16:creationId xmlns:a16="http://schemas.microsoft.com/office/drawing/2014/main" id="{32AA29B7-4A45-3F56-B0DE-86B16778596C}"/>
+                <a16:creationId xmlns:a16="http://schemas.microsoft.com/office/drawing/2014/main" id="{7E941BCC-04C3-1456-F746-EB363313BA03}"/>
               </a:ext>
             </a:extLst>
           </p:cNvPr>
@@ -4510,14 +4474,14 @@
         </p:nvSpPr>
         <p:spPr>
           <a:xfrm>
-            <a:off x="4552511" y="1354994"/>
+            <a:off x="3847289" y="1362312"/>
             <a:ext cx="152458" cy="136543"/>
           </a:xfrm>
           <a:prstGeom prst="roundRect">
             <a:avLst/>
           </a:prstGeom>
           <a:solidFill>
-            <a:schemeClr val="accent2">
+            <a:schemeClr val="accent5">
               <a:lumMod val="20000"/>
               <a:lumOff val="80000"/>
             </a:schemeClr>
@@ -4550,10 +4514,10 @@
       </p:sp>
       <p:sp>
         <p:nvSpPr>
-          <p:cNvPr id="139" name="ZoneTexte 138">
+          <p:cNvPr id="135" name="ZoneTexte 134">
             <a:extLst>
               <a:ext uri="{FF2B5EF4-FFF2-40B4-BE49-F238E27FC236}">
-                <a16:creationId xmlns:a16="http://schemas.microsoft.com/office/drawing/2014/main" id="{AC40E083-3C78-FC45-205B-7BAE13FDA777}"/>
+                <a16:creationId xmlns:a16="http://schemas.microsoft.com/office/drawing/2014/main" id="{F8D97D9F-345F-FD52-E860-E64F2756361F}"/>
               </a:ext>
             </a:extLst>
           </p:cNvPr>
@@ -4562,7 +4526,7 @@
         </p:nvSpPr>
         <p:spPr>
           <a:xfrm>
-            <a:off x="4821778" y="1308548"/>
+            <a:off x="4151079" y="1315164"/>
             <a:ext cx="401072" cy="230832"/>
           </a:xfrm>
           <a:prstGeom prst="rect">
@@ -4585,10 +4549,10 @@
       </p:sp>
       <p:sp>
         <p:nvSpPr>
-          <p:cNvPr id="140" name="Rectangle : coins arrondis 139">
+          <p:cNvPr id="137" name="Rectangle : coins arrondis 136">
             <a:extLst>
               <a:ext uri="{FF2B5EF4-FFF2-40B4-BE49-F238E27FC236}">
-                <a16:creationId xmlns:a16="http://schemas.microsoft.com/office/drawing/2014/main" id="{F609820A-3B2C-0CA3-6778-55A4A69CEE48}"/>
+                <a16:creationId xmlns:a16="http://schemas.microsoft.com/office/drawing/2014/main" id="{32AA29B7-4A45-3F56-B0DE-86B16778596C}"/>
               </a:ext>
             </a:extLst>
           </p:cNvPr>
@@ -4597,15 +4561,16 @@
         </p:nvSpPr>
         <p:spPr>
           <a:xfrm>
-            <a:off x="4981347" y="1750493"/>
+            <a:off x="4675698" y="1354994"/>
             <a:ext cx="152458" cy="136543"/>
           </a:xfrm>
           <a:prstGeom prst="roundRect">
             <a:avLst/>
           </a:prstGeom>
           <a:solidFill>
-            <a:schemeClr val="bg2">
-              <a:lumMod val="50000"/>
+            <a:schemeClr val="accent2">
+              <a:lumMod val="20000"/>
+              <a:lumOff val="80000"/>
             </a:schemeClr>
           </a:solidFill>
         </p:spPr>
@@ -4636,6 +4601,92 @@
       </p:sp>
       <p:sp>
         <p:nvSpPr>
+          <p:cNvPr id="139" name="ZoneTexte 138">
+            <a:extLst>
+              <a:ext uri="{FF2B5EF4-FFF2-40B4-BE49-F238E27FC236}">
+                <a16:creationId xmlns:a16="http://schemas.microsoft.com/office/drawing/2014/main" id="{AC40E083-3C78-FC45-205B-7BAE13FDA777}"/>
+              </a:ext>
+            </a:extLst>
+          </p:cNvPr>
+          <p:cNvSpPr txBox="1"/>
+          <p:nvPr/>
+        </p:nvSpPr>
+        <p:spPr>
+          <a:xfrm>
+            <a:off x="4944965" y="1308548"/>
+            <a:ext cx="401072" cy="230832"/>
+          </a:xfrm>
+          <a:prstGeom prst="rect">
+            <a:avLst/>
+          </a:prstGeom>
+          <a:noFill/>
+        </p:spPr>
+        <p:txBody>
+          <a:bodyPr wrap="none" rtlCol="0">
+            <a:spAutoFit/>
+          </a:bodyPr>
+          <a:lstStyle/>
+          <a:p>
+            <a:r>
+              <a:rPr lang="fr-FR" sz="900" b="1" dirty="0"/>
+              <a:t>*M7</a:t>
+            </a:r>
+          </a:p>
+        </p:txBody>
+      </p:sp>
+      <p:sp>
+        <p:nvSpPr>
+          <p:cNvPr id="140" name="Rectangle : coins arrondis 139">
+            <a:extLst>
+              <a:ext uri="{FF2B5EF4-FFF2-40B4-BE49-F238E27FC236}">
+                <a16:creationId xmlns:a16="http://schemas.microsoft.com/office/drawing/2014/main" id="{F609820A-3B2C-0CA3-6778-55A4A69CEE48}"/>
+              </a:ext>
+            </a:extLst>
+          </p:cNvPr>
+          <p:cNvSpPr/>
+          <p:nvPr/>
+        </p:nvSpPr>
+        <p:spPr>
+          <a:xfrm>
+            <a:off x="5104534" y="1750493"/>
+            <a:ext cx="152458" cy="136543"/>
+          </a:xfrm>
+          <a:prstGeom prst="roundRect">
+            <a:avLst/>
+          </a:prstGeom>
+          <a:solidFill>
+            <a:schemeClr val="bg2">
+              <a:lumMod val="50000"/>
+            </a:schemeClr>
+          </a:solidFill>
+        </p:spPr>
+        <p:style>
+          <a:lnRef idx="2">
+            <a:schemeClr val="accent1">
+              <a:shade val="15000"/>
+            </a:schemeClr>
+          </a:lnRef>
+          <a:fillRef idx="1">
+            <a:schemeClr val="accent1"/>
+          </a:fillRef>
+          <a:effectRef idx="0">
+            <a:schemeClr val="accent1"/>
+          </a:effectRef>
+          <a:fontRef idx="minor">
+            <a:schemeClr val="lt1"/>
+          </a:fontRef>
+        </p:style>
+        <p:txBody>
+          <a:bodyPr rtlCol="0" anchor="ctr"/>
+          <a:lstStyle/>
+          <a:p>
+            <a:pPr algn="ctr"/>
+            <a:endParaRPr lang="fr-FR" sz="900"/>
+          </a:p>
+        </p:txBody>
+      </p:sp>
+      <p:sp>
+        <p:nvSpPr>
           <p:cNvPr id="7" name="ZoneTexte 6">
             <a:extLst>
               <a:ext uri="{FF2B5EF4-FFF2-40B4-BE49-F238E27FC236}">
@@ -4648,8 +4699,8 @@
         </p:nvSpPr>
         <p:spPr>
           <a:xfrm>
-            <a:off x="2967544" y="1738353"/>
-            <a:ext cx="2120696" cy="184666"/>
+            <a:off x="3418536" y="1599668"/>
+            <a:ext cx="1194916" cy="276999"/>
           </a:xfrm>
           <a:prstGeom prst="rect">
             <a:avLst/>
@@ -4684,8 +4735,8 @@
         </p:nvSpPr>
         <p:spPr>
           <a:xfrm>
-            <a:off x="895295" y="37540"/>
-            <a:ext cx="722858" cy="184666"/>
+            <a:off x="1204236" y="46864"/>
+            <a:ext cx="642458" cy="184666"/>
           </a:xfrm>
           <a:prstGeom prst="rect">
             <a:avLst/>
@@ -4698,9 +4749,10 @@
           </a:bodyPr>
           <a:lstStyle/>
           <a:p>
+            <a:pPr algn="ctr"/>
             <a:r>
               <a:rPr lang="en-GB" sz="600" b="1" dirty="0"/>
-              <a:t>biochemical</a:t>
+              <a:t>Biochemical</a:t>
             </a:r>
           </a:p>
         </p:txBody>
@@ -4719,7 +4771,7 @@
         </p:nvSpPr>
         <p:spPr>
           <a:xfrm>
-            <a:off x="2007270" y="30027"/>
+            <a:off x="2195093" y="39345"/>
             <a:ext cx="1343342" cy="184666"/>
           </a:xfrm>
           <a:prstGeom prst="rect">
@@ -4733,7 +4785,7 @@
           </a:bodyPr>
           <a:lstStyle/>
           <a:p>
-            <a:pPr algn="just"/>
+            <a:pPr algn="ctr"/>
             <a:r>
               <a:rPr lang="en-GB" sz="600" b="1" dirty="0"/>
               <a:t>Mid-infrared spectroscopy</a:t>
@@ -4755,7 +4807,7 @@
         </p:nvSpPr>
         <p:spPr>
           <a:xfrm>
-            <a:off x="3693008" y="18457"/>
+            <a:off x="3859219" y="40441"/>
             <a:ext cx="873630" cy="184666"/>
           </a:xfrm>
           <a:prstGeom prst="rect">
@@ -4769,10 +4821,10 @@
           </a:bodyPr>
           <a:lstStyle/>
           <a:p>
-            <a:pPr algn="just"/>
+            <a:pPr algn="ctr"/>
             <a:r>
               <a:rPr lang="en-GB" sz="600" b="1" dirty="0" err="1"/>
-              <a:t>metallomic</a:t>
+              <a:t>Metallomic</a:t>
             </a:r>
             <a:endParaRPr lang="en-GB" sz="600" b="1" dirty="0"/>
           </a:p>
@@ -4917,8 +4969,8 @@
         </p:blipFill>
         <p:spPr>
           <a:xfrm>
-            <a:off x="223455" y="1028794"/>
-            <a:ext cx="239348" cy="239348"/>
+            <a:off x="172941" y="1028794"/>
+            <a:ext cx="326200" cy="326200"/>
           </a:xfrm>
           <a:prstGeom prst="rect">
             <a:avLst/>
@@ -4939,7 +4991,7 @@
         </p:nvSpPr>
         <p:spPr>
           <a:xfrm rot="16200000">
-            <a:off x="1309193" y="1193080"/>
+            <a:off x="1228647" y="1193080"/>
             <a:ext cx="144467" cy="99705"/>
           </a:xfrm>
           <a:prstGeom prst="leftArrow">
@@ -4991,7 +5043,7 @@
         </p:nvSpPr>
         <p:spPr>
           <a:xfrm rot="16200000">
-            <a:off x="1622434" y="1193079"/>
+            <a:off x="1461346" y="1193079"/>
             <a:ext cx="144467" cy="99705"/>
           </a:xfrm>
           <a:prstGeom prst="leftArrow">
@@ -5043,7 +5095,7 @@
         </p:nvSpPr>
         <p:spPr>
           <a:xfrm rot="16200000">
-            <a:off x="2558754" y="1195240"/>
+            <a:off x="2681934" y="1195240"/>
             <a:ext cx="144467" cy="99705"/>
           </a:xfrm>
           <a:prstGeom prst="leftArrow">
@@ -5095,7 +5147,7 @@
         </p:nvSpPr>
         <p:spPr>
           <a:xfrm rot="16200000">
-            <a:off x="3326926" y="1179897"/>
+            <a:off x="3450113" y="1179897"/>
             <a:ext cx="144467" cy="99705"/>
           </a:xfrm>
           <a:prstGeom prst="leftArrow">
@@ -5147,7 +5199,7 @@
         </p:nvSpPr>
         <p:spPr>
           <a:xfrm rot="10800000">
-            <a:off x="3549698" y="1383703"/>
+            <a:off x="3672885" y="1383703"/>
             <a:ext cx="144467" cy="99705"/>
           </a:xfrm>
           <a:prstGeom prst="leftArrow">
@@ -5199,7 +5251,7 @@
         </p:nvSpPr>
         <p:spPr>
           <a:xfrm rot="10800000">
-            <a:off x="3947117" y="1380730"/>
+            <a:off x="4070304" y="1380730"/>
             <a:ext cx="144467" cy="99705"/>
           </a:xfrm>
           <a:prstGeom prst="leftArrow">
@@ -5252,9 +5304,9 @@
           <p:nvPr/>
         </p:nvCxnSpPr>
         <p:spPr>
-          <a:xfrm flipV="1">
-            <a:off x="895295" y="469123"/>
-            <a:ext cx="4327926" cy="14101"/>
+          <a:xfrm>
+            <a:off x="834491" y="489754"/>
+            <a:ext cx="4507200" cy="0"/>
           </a:xfrm>
           <a:prstGeom prst="line">
             <a:avLst/>
@@ -5290,7 +5342,7 @@
         </p:nvSpPr>
         <p:spPr>
           <a:xfrm rot="16200000">
-            <a:off x="2577978" y="1610778"/>
+            <a:off x="2701158" y="1606040"/>
             <a:ext cx="106014" cy="55404"/>
           </a:xfrm>
           <a:prstGeom prst="leftArrow">
@@ -5343,9 +5395,9 @@
           <p:nvPr/>
         </p:nvCxnSpPr>
         <p:spPr>
-          <a:xfrm flipV="1">
-            <a:off x="836828" y="1552527"/>
-            <a:ext cx="4386022" cy="20040"/>
+          <a:xfrm>
+            <a:off x="836828" y="1572567"/>
+            <a:ext cx="4509209" cy="0"/>
           </a:xfrm>
           <a:prstGeom prst="line">
             <a:avLst/>
@@ -5381,7 +5433,7 @@
         </p:nvSpPr>
         <p:spPr>
           <a:xfrm rot="10800000">
-            <a:off x="4365277" y="1373414"/>
+            <a:off x="4488464" y="1373414"/>
             <a:ext cx="144467" cy="99705"/>
           </a:xfrm>
           <a:prstGeom prst="leftArrow">
@@ -5433,7 +5485,7 @@
         </p:nvSpPr>
         <p:spPr>
           <a:xfrm rot="10800000">
-            <a:off x="4743824" y="1369212"/>
+            <a:off x="4867011" y="1369212"/>
             <a:ext cx="144467" cy="99705"/>
           </a:xfrm>
           <a:prstGeom prst="leftArrow">
@@ -5537,7 +5589,7 @@
         </p:nvSpPr>
         <p:spPr>
           <a:xfrm rot="16200000">
-            <a:off x="1327709" y="1610778"/>
+            <a:off x="1247163" y="1610778"/>
             <a:ext cx="106014" cy="55404"/>
           </a:xfrm>
           <a:prstGeom prst="leftArrow">
@@ -5589,7 +5641,7 @@
         </p:nvSpPr>
         <p:spPr>
           <a:xfrm rot="16200000">
-            <a:off x="5004569" y="1600114"/>
+            <a:off x="5127756" y="1609016"/>
             <a:ext cx="106014" cy="55404"/>
           </a:xfrm>
           <a:prstGeom prst="leftArrow">
@@ -5641,7 +5693,7 @@
         </p:nvSpPr>
         <p:spPr>
           <a:xfrm rot="16200000">
-            <a:off x="1640525" y="1610777"/>
+            <a:off x="1479437" y="1610777"/>
             <a:ext cx="106014" cy="55404"/>
           </a:xfrm>
           <a:prstGeom prst="leftArrow">
@@ -5734,7 +5786,7 @@
         </p:nvSpPr>
         <p:spPr>
           <a:xfrm>
-            <a:off x="1077402" y="230058"/>
+            <a:off x="1439261" y="234795"/>
             <a:ext cx="152458" cy="136543"/>
           </a:xfrm>
           <a:prstGeom prst="roundRect">
@@ -5786,7 +5838,7 @@
         </p:nvSpPr>
         <p:spPr>
           <a:xfrm>
-            <a:off x="2428676" y="226030"/>
+            <a:off x="2790535" y="230767"/>
             <a:ext cx="152458" cy="136543"/>
           </a:xfrm>
           <a:prstGeom prst="roundRect">
@@ -5838,7 +5890,7 @@
         </p:nvSpPr>
         <p:spPr>
           <a:xfrm>
-            <a:off x="3876560" y="230058"/>
+            <a:off x="4238419" y="234795"/>
             <a:ext cx="152458" cy="136543"/>
           </a:xfrm>
           <a:prstGeom prst="roundRect">
@@ -6029,6 +6081,196 @@
           <a:p>
             <a:pPr algn="ctr"/>
             <a:endParaRPr lang="fr-FR" sz="900"/>
+          </a:p>
+        </p:txBody>
+      </p:sp>
+      <p:sp>
+        <p:nvSpPr>
+          <p:cNvPr id="11" name="Flèche vers la gauche 102">
+            <a:extLst>
+              <a:ext uri="{FF2B5EF4-FFF2-40B4-BE49-F238E27FC236}">
+                <a16:creationId xmlns:a16="http://schemas.microsoft.com/office/drawing/2014/main" id="{81175E17-34A4-8B63-41B2-F23F72E45CEA}"/>
+              </a:ext>
+            </a:extLst>
+          </p:cNvPr>
+          <p:cNvSpPr/>
+          <p:nvPr/>
+        </p:nvSpPr>
+        <p:spPr>
+          <a:xfrm rot="10800000">
+            <a:off x="2033460" y="1787815"/>
+            <a:ext cx="106014" cy="55404"/>
+          </a:xfrm>
+          <a:prstGeom prst="leftArrow">
+            <a:avLst/>
+          </a:prstGeom>
+          <a:solidFill>
+            <a:srgbClr val="0070C0"/>
+          </a:solidFill>
+          <a:ln>
+            <a:solidFill>
+              <a:srgbClr val="0070C0"/>
+            </a:solidFill>
+          </a:ln>
+        </p:spPr>
+        <p:style>
+          <a:lnRef idx="3">
+            <a:schemeClr val="lt1"/>
+          </a:lnRef>
+          <a:fillRef idx="1">
+            <a:schemeClr val="dk1"/>
+          </a:fillRef>
+          <a:effectRef idx="1">
+            <a:schemeClr val="dk1"/>
+          </a:effectRef>
+          <a:fontRef idx="minor">
+            <a:schemeClr val="lt1"/>
+          </a:fontRef>
+        </p:style>
+        <p:txBody>
+          <a:bodyPr rtlCol="0" anchor="ctr"/>
+          <a:lstStyle/>
+          <a:p>
+            <a:pPr algn="ctr"/>
+            <a:endParaRPr lang="fr-FR" sz="900"/>
+          </a:p>
+        </p:txBody>
+      </p:sp>
+      <p:sp>
+        <p:nvSpPr>
+          <p:cNvPr id="15" name="Rectangle : coins arrondis 14">
+            <a:extLst>
+              <a:ext uri="{FF2B5EF4-FFF2-40B4-BE49-F238E27FC236}">
+                <a16:creationId xmlns:a16="http://schemas.microsoft.com/office/drawing/2014/main" id="{1F4DA8F1-87FF-2DFA-BC94-047637A70139}"/>
+              </a:ext>
+            </a:extLst>
+          </p:cNvPr>
+          <p:cNvSpPr/>
+          <p:nvPr/>
+        </p:nvSpPr>
+        <p:spPr>
+          <a:xfrm>
+            <a:off x="2177136" y="1750492"/>
+            <a:ext cx="152458" cy="136543"/>
+          </a:xfrm>
+          <a:prstGeom prst="roundRect">
+            <a:avLst/>
+          </a:prstGeom>
+          <a:solidFill>
+            <a:schemeClr val="bg2">
+              <a:lumMod val="50000"/>
+            </a:schemeClr>
+          </a:solidFill>
+        </p:spPr>
+        <p:style>
+          <a:lnRef idx="2">
+            <a:schemeClr val="accent1">
+              <a:shade val="15000"/>
+            </a:schemeClr>
+          </a:lnRef>
+          <a:fillRef idx="1">
+            <a:schemeClr val="accent1"/>
+          </a:fillRef>
+          <a:effectRef idx="0">
+            <a:schemeClr val="accent1"/>
+          </a:effectRef>
+          <a:fontRef idx="minor">
+            <a:schemeClr val="lt1"/>
+          </a:fontRef>
+        </p:style>
+        <p:txBody>
+          <a:bodyPr rtlCol="0" anchor="ctr"/>
+          <a:lstStyle/>
+          <a:p>
+            <a:pPr algn="ctr"/>
+            <a:endParaRPr lang="fr-FR" sz="900"/>
+          </a:p>
+        </p:txBody>
+      </p:sp>
+      <p:sp>
+        <p:nvSpPr>
+          <p:cNvPr id="21" name="Flèche vers la gauche 102">
+            <a:extLst>
+              <a:ext uri="{FF2B5EF4-FFF2-40B4-BE49-F238E27FC236}">
+                <a16:creationId xmlns:a16="http://schemas.microsoft.com/office/drawing/2014/main" id="{0D5CE928-7907-6D86-3D69-EEB1FBC19C37}"/>
+              </a:ext>
+            </a:extLst>
+          </p:cNvPr>
+          <p:cNvSpPr/>
+          <p:nvPr/>
+        </p:nvSpPr>
+        <p:spPr>
+          <a:xfrm rot="10800000">
+            <a:off x="1655557" y="1765664"/>
+            <a:ext cx="144467" cy="99705"/>
+          </a:xfrm>
+          <a:prstGeom prst="leftArrow">
+            <a:avLst/>
+          </a:prstGeom>
+          <a:solidFill>
+            <a:schemeClr val="bg2">
+              <a:lumMod val="75000"/>
+            </a:schemeClr>
+          </a:solidFill>
+          <a:ln>
+            <a:noFill/>
+          </a:ln>
+        </p:spPr>
+        <p:style>
+          <a:lnRef idx="3">
+            <a:schemeClr val="lt1"/>
+          </a:lnRef>
+          <a:fillRef idx="1">
+            <a:schemeClr val="dk1"/>
+          </a:fillRef>
+          <a:effectRef idx="1">
+            <a:schemeClr val="dk1"/>
+          </a:effectRef>
+          <a:fontRef idx="minor">
+            <a:schemeClr val="lt1"/>
+          </a:fontRef>
+        </p:style>
+        <p:txBody>
+          <a:bodyPr rtlCol="0" anchor="ctr"/>
+          <a:lstStyle/>
+          <a:p>
+            <a:pPr algn="ctr"/>
+            <a:endParaRPr lang="fr-FR" sz="900"/>
+          </a:p>
+        </p:txBody>
+      </p:sp>
+      <p:sp>
+        <p:nvSpPr>
+          <p:cNvPr id="22" name="ZoneTexte 21">
+            <a:extLst>
+              <a:ext uri="{FF2B5EF4-FFF2-40B4-BE49-F238E27FC236}">
+                <a16:creationId xmlns:a16="http://schemas.microsoft.com/office/drawing/2014/main" id="{FE44DE4C-525D-14A2-84E4-5CECD9E78CEC}"/>
+              </a:ext>
+            </a:extLst>
+          </p:cNvPr>
+          <p:cNvSpPr txBox="1"/>
+          <p:nvPr/>
+        </p:nvSpPr>
+        <p:spPr>
+          <a:xfrm>
+            <a:off x="1733916" y="1686749"/>
+            <a:ext cx="343364" cy="230832"/>
+          </a:xfrm>
+          <a:prstGeom prst="rect">
+            <a:avLst/>
+          </a:prstGeom>
+          <a:noFill/>
+        </p:spPr>
+        <p:txBody>
+          <a:bodyPr wrap="none" rtlCol="0">
+            <a:spAutoFit/>
+          </a:bodyPr>
+          <a:lstStyle/>
+          <a:p>
+            <a:r>
+              <a:rPr lang="fr-FR" sz="900" b="1" dirty="0"/>
+              <a:t>M4</a:t>
+            </a:r>
           </a:p>
         </p:txBody>
       </p:sp>

</xml_diff>